<commit_message>
adjusted with instructions to use local db
</commit_message>
<xml_diff>
--- a/Web message board.pptx
+++ b/Web message board.pptx
@@ -5,16 +5,17 @@
     <p:sldMasterId id="2147483870" r:id="rId4"/>
   </p:sldMasterIdLst>
   <p:notesMasterIdLst>
-    <p:notesMasterId r:id="rId12"/>
+    <p:notesMasterId r:id="rId13"/>
   </p:notesMasterIdLst>
   <p:sldIdLst>
     <p:sldId id="2767" r:id="rId5"/>
     <p:sldId id="257" r:id="rId6"/>
     <p:sldId id="2771" r:id="rId7"/>
-    <p:sldId id="2773" r:id="rId8"/>
-    <p:sldId id="2774" r:id="rId9"/>
-    <p:sldId id="2772" r:id="rId10"/>
-    <p:sldId id="2775" r:id="rId11"/>
+    <p:sldId id="2776" r:id="rId8"/>
+    <p:sldId id="2773" r:id="rId9"/>
+    <p:sldId id="2774" r:id="rId10"/>
+    <p:sldId id="2772" r:id="rId11"/>
+    <p:sldId id="2775" r:id="rId12"/>
   </p:sldIdLst>
   <p:sldSz cx="12192000" cy="6858000"/>
   <p:notesSz cx="6858000" cy="9144000"/>
@@ -202,7 +203,7 @@
           </a:lstStyle>
           <a:p>
             <a:fld id="{3C2D05EE-1874-40CA-ACBB-AAFE8CEAEC56}" type="datetimeFigureOut">
-              <a:t>3/16/2026</a:t>
+              <a:t>3/23/2026</a:t>
             </a:fld>
             <a:endParaRPr lang="en-US" dirty="0"/>
           </a:p>
@@ -694,7 +695,7 @@
           <a:p>
             <a:fld id="{509B9498-FDEE-4498-AC3A-C83DFCC8A50A}" type="slidenum">
               <a:rPr lang="en-US" smtClean="0"/>
-              <a:t>7</a:t>
+              <a:t>8</a:t>
             </a:fld>
             <a:endParaRPr lang="en-US" dirty="0"/>
           </a:p>
@@ -965,7 +966,7 @@
           <a:p>
             <a:fld id="{FC2791E5-06A8-47CF-B0F8-238D8A98DD3A}" type="datetime1">
               <a:rPr lang="en-US" smtClean="0"/>
-              <a:t>3/18/2026</a:t>
+              <a:t>3/23/2026</a:t>
             </a:fld>
             <a:endParaRPr lang="en-US" dirty="0"/>
           </a:p>
@@ -1237,7 +1238,7 @@
           <a:p>
             <a:fld id="{452745B6-6146-4FA7-BE23-4E8C60EB6CBC}" type="datetime1">
               <a:rPr lang="en-US" smtClean="0"/>
-              <a:t>3/18/2026</a:t>
+              <a:t>3/23/2026</a:t>
             </a:fld>
             <a:endParaRPr lang="en-US" dirty="0"/>
           </a:p>
@@ -1477,7 +1478,7 @@
           <a:p>
             <a:fld id="{54472B72-E800-4A97-940B-DD3BDA28818E}" type="datetime1">
               <a:rPr lang="en-US" smtClean="0"/>
-              <a:t>3/18/2026</a:t>
+              <a:t>3/23/2026</a:t>
             </a:fld>
             <a:endParaRPr lang="en-US" dirty="0"/>
           </a:p>
@@ -1740,7 +1741,7 @@
           <a:p>
             <a:fld id="{B1C29E05-9F4D-41B7-9528-DB9936DEF0DF}" type="datetime1">
               <a:rPr lang="en-US" smtClean="0"/>
-              <a:t>3/18/2026</a:t>
+              <a:t>3/23/2026</a:t>
             </a:fld>
             <a:endParaRPr lang="en-US" dirty="0"/>
           </a:p>
@@ -2107,7 +2108,7 @@
           <a:p>
             <a:fld id="{41921A07-93EA-409B-8C0E-9CB9DCAB74C9}" type="datetime1">
               <a:rPr lang="en-US" smtClean="0"/>
-              <a:t>3/18/2026</a:t>
+              <a:t>3/23/2026</a:t>
             </a:fld>
             <a:endParaRPr lang="en-US" dirty="0"/>
           </a:p>
@@ -2510,7 +2511,7 @@
           <a:p>
             <a:fld id="{A2E7FB8A-9096-4D4A-8F17-1B38291FBDD9}" type="datetime1">
               <a:rPr lang="en-US" smtClean="0"/>
-              <a:t>3/18/2026</a:t>
+              <a:t>3/23/2026</a:t>
             </a:fld>
             <a:endParaRPr lang="en-US" dirty="0"/>
           </a:p>
@@ -2901,7 +2902,7 @@
           <a:p>
             <a:fld id="{FFAAA0A8-8FC0-4282-9BFC-0DF8B5C8C49A}" type="datetime1">
               <a:rPr lang="en-US" smtClean="0"/>
-              <a:t>3/18/2026</a:t>
+              <a:t>3/23/2026</a:t>
             </a:fld>
             <a:endParaRPr lang="en-US" dirty="0"/>
           </a:p>
@@ -3292,7 +3293,7 @@
           <a:p>
             <a:fld id="{9956F777-1047-4221-8EDB-19F67E41821E}" type="datetime1">
               <a:rPr lang="en-US" smtClean="0"/>
-              <a:t>3/18/2026</a:t>
+              <a:t>3/23/2026</a:t>
             </a:fld>
             <a:endParaRPr lang="en-US" dirty="0"/>
           </a:p>
@@ -3696,7 +3697,7 @@
           <a:p>
             <a:fld id="{9AABE01F-463E-4240-AE91-97F32D93E708}" type="datetime1">
               <a:rPr lang="en-US" smtClean="0"/>
-              <a:t>3/18/2026</a:t>
+              <a:t>3/23/2026</a:t>
             </a:fld>
             <a:endParaRPr lang="en-US" dirty="0"/>
           </a:p>
@@ -4095,7 +4096,7 @@
           <a:p>
             <a:fld id="{08CAD835-60C8-4279-855E-E9C4800F201C}" type="datetime1">
               <a:rPr lang="en-US" smtClean="0"/>
-              <a:t>3/18/2026</a:t>
+              <a:t>3/23/2026</a:t>
             </a:fld>
             <a:endParaRPr lang="en-US" dirty="0"/>
           </a:p>
@@ -4330,7 +4331,7 @@
           <a:p>
             <a:fld id="{712D55FB-44BC-4C39-9156-797CB9E10112}" type="datetime1">
               <a:rPr lang="en-US" smtClean="0"/>
-              <a:t>3/18/2026</a:t>
+              <a:t>3/23/2026</a:t>
             </a:fld>
             <a:endParaRPr lang="en-US" dirty="0"/>
           </a:p>
@@ -4571,7 +4572,7 @@
           <a:p>
             <a:fld id="{ABAD6FCE-24C9-4278-AE9E-0ABD39A37752}" type="datetime1">
               <a:rPr lang="en-US" smtClean="0"/>
-              <a:t>3/18/2026</a:t>
+              <a:t>3/23/2026</a:t>
             </a:fld>
             <a:endParaRPr lang="en-US" dirty="0"/>
           </a:p>
@@ -4800,7 +4801,7 @@
           <a:p>
             <a:fld id="{0E52F911-824B-4A2F-98DF-C6E402EFE13D}" type="datetime1">
               <a:rPr lang="en-US" smtClean="0"/>
-              <a:t>3/18/2026</a:t>
+              <a:t>3/23/2026</a:t>
             </a:fld>
             <a:endParaRPr lang="en-US" dirty="0"/>
           </a:p>
@@ -5017,7 +5018,7 @@
           <a:p>
             <a:fld id="{B8C4254D-E30B-40AF-A175-B550243C71B9}" type="datetime1">
               <a:rPr lang="en-US" smtClean="0"/>
-              <a:t>3/18/2026</a:t>
+              <a:t>3/23/2026</a:t>
             </a:fld>
             <a:endParaRPr lang="en-US" dirty="0"/>
           </a:p>
@@ -5252,7 +5253,7 @@
           <a:p>
             <a:fld id="{953A0270-163C-42DF-807F-F4CF09CC02C0}" type="datetime1">
               <a:rPr lang="en-US" smtClean="0"/>
-              <a:t>3/18/2026</a:t>
+              <a:t>3/23/2026</a:t>
             </a:fld>
             <a:endParaRPr lang="en-US" dirty="0"/>
           </a:p>
@@ -5469,7 +5470,7 @@
           <a:p>
             <a:fld id="{682AF418-40E1-40D6-AADC-DD9A9B7FD2A3}" type="datetime1">
               <a:rPr lang="en-US" smtClean="0"/>
-              <a:t>3/18/2026</a:t>
+              <a:t>3/23/2026</a:t>
             </a:fld>
             <a:endParaRPr lang="en-US" dirty="0"/>
           </a:p>
@@ -5789,7 +5790,7 @@
           <a:p>
             <a:fld id="{70CEB154-A10D-4EAD-B0D3-2686CEE601D0}" type="datetime1">
               <a:rPr lang="en-US" smtClean="0"/>
-              <a:t>3/18/2026</a:t>
+              <a:t>3/23/2026</a:t>
             </a:fld>
             <a:endParaRPr lang="en-US" dirty="0"/>
           </a:p>
@@ -6137,7 +6138,7 @@
           <a:p>
             <a:fld id="{C8347396-53EC-4909-9CC1-4038CF93EB9F}" type="datetime1">
               <a:rPr lang="en-US" smtClean="0"/>
-              <a:t>3/18/2026</a:t>
+              <a:t>3/23/2026</a:t>
             </a:fld>
             <a:endParaRPr lang="en-US" dirty="0"/>
           </a:p>
@@ -6484,7 +6485,7 @@
           <a:p>
             <a:fld id="{C8E59098-1FCC-4EDB-8CD5-A2765AD0BB32}" type="datetime1">
               <a:rPr lang="en-US" smtClean="0"/>
-              <a:t>3/18/2026</a:t>
+              <a:t>3/23/2026</a:t>
             </a:fld>
             <a:endParaRPr lang="en-US" dirty="0"/>
           </a:p>
@@ -6831,7 +6832,7 @@
           <a:p>
             <a:fld id="{70866996-864E-44EE-AA04-2CCB121E0774}" type="datetime1">
               <a:rPr lang="en-US" smtClean="0"/>
-              <a:t>3/18/2026</a:t>
+              <a:t>3/23/2026</a:t>
             </a:fld>
             <a:endParaRPr lang="en-US" dirty="0"/>
           </a:p>
@@ -7185,7 +7186,7 @@
           <a:p>
             <a:fld id="{12650E1C-6C33-4E5A-9C37-B18B76C05F1B}" type="datetime1">
               <a:rPr lang="en-US" smtClean="0"/>
-              <a:t>3/18/2026</a:t>
+              <a:t>3/23/2026</a:t>
             </a:fld>
             <a:endParaRPr lang="en-US" dirty="0"/>
           </a:p>
@@ -7552,7 +7553,7 @@
           <a:p>
             <a:fld id="{268AD81D-ABEC-41DF-90B8-C8C950493824}" type="datetime1">
               <a:rPr lang="en-US" smtClean="0"/>
-              <a:t>3/18/2026</a:t>
+              <a:t>3/23/2026</a:t>
             </a:fld>
             <a:endParaRPr lang="en-US" dirty="0"/>
           </a:p>
@@ -7879,7 +7880,7 @@
           <a:p>
             <a:fld id="{C724FDE9-DC7C-4650-A2AA-695EFC7BC855}" type="datetime1">
               <a:rPr lang="en-US" smtClean="0"/>
-              <a:t>3/18/2026</a:t>
+              <a:t>3/23/2026</a:t>
             </a:fld>
             <a:endParaRPr lang="en-US" dirty="0"/>
           </a:p>
@@ -8248,7 +8249,7 @@
           <a:p>
             <a:fld id="{A8791641-C1ED-415C-8ADC-8828ADE9ACB0}" type="datetime1">
               <a:rPr lang="en-US" smtClean="0"/>
-              <a:t>3/18/2026</a:t>
+              <a:t>3/23/2026</a:t>
             </a:fld>
             <a:endParaRPr lang="en-US" dirty="0"/>
           </a:p>
@@ -8603,7 +8604,7 @@
           <a:p>
             <a:fld id="{6B127B6E-C607-4258-96BF-DE7EED0A69C8}" type="datetime1">
               <a:rPr lang="en-US" smtClean="0"/>
-              <a:t>3/18/2026</a:t>
+              <a:t>3/23/2026</a:t>
             </a:fld>
             <a:endParaRPr lang="en-US" dirty="0"/>
           </a:p>
@@ -8932,7 +8933,7 @@
           <a:p>
             <a:fld id="{3B9234DF-8584-4FD6-A75D-31609BD7243D}" type="datetime1">
               <a:rPr lang="en-US" smtClean="0"/>
-              <a:t>3/18/2026</a:t>
+              <a:t>3/23/2026</a:t>
             </a:fld>
             <a:endParaRPr lang="en-US" dirty="0"/>
           </a:p>
@@ -9252,7 +9253,7 @@
           <a:p>
             <a:fld id="{350F2502-0B71-47DD-B623-812D9E6CE49F}" type="datetime1">
               <a:rPr lang="en-US" smtClean="0"/>
-              <a:t>3/18/2026</a:t>
+              <a:t>3/23/2026</a:t>
             </a:fld>
             <a:endParaRPr lang="en-US" dirty="0"/>
           </a:p>
@@ -9600,7 +9601,7 @@
           <a:p>
             <a:fld id="{C49B1CAB-E8CA-4A0B-A9A4-575C9FAA8BFF}" type="datetime1">
               <a:rPr lang="en-US" smtClean="0"/>
-              <a:t>3/18/2026</a:t>
+              <a:t>3/23/2026</a:t>
             </a:fld>
             <a:endParaRPr lang="en-US" dirty="0"/>
           </a:p>
@@ -9920,7 +9921,7 @@
           <a:p>
             <a:fld id="{E1FC9F75-7026-415E-8400-5A012EC3AAA3}" type="datetime1">
               <a:rPr lang="en-US" smtClean="0"/>
-              <a:t>3/18/2026</a:t>
+              <a:t>3/23/2026</a:t>
             </a:fld>
             <a:endParaRPr lang="en-US" dirty="0"/>
           </a:p>
@@ -10264,7 +10265,7 @@
           <a:p>
             <a:fld id="{BC5A95C0-AC4F-4C47-A7E5-46F23F95FC89}" type="datetime1">
               <a:rPr lang="en-US" smtClean="0"/>
-              <a:t>3/18/2026</a:t>
+              <a:t>3/23/2026</a:t>
             </a:fld>
             <a:endParaRPr lang="en-US" dirty="0"/>
           </a:p>
@@ -10598,7 +10599,7 @@
           <a:p>
             <a:fld id="{167B52D4-14D0-4264-9CD0-01E659A855E2}" type="datetime1">
               <a:rPr lang="en-US" smtClean="0"/>
-              <a:t>3/18/2026</a:t>
+              <a:t>3/23/2026</a:t>
             </a:fld>
             <a:endParaRPr lang="en-US" dirty="0"/>
           </a:p>
@@ -10918,7 +10919,7 @@
           <a:p>
             <a:fld id="{989ED3CC-61A7-4F32-8D8C-3238A2AD6F0D}" type="datetime1">
               <a:rPr lang="en-US" smtClean="0"/>
-              <a:t>3/18/2026</a:t>
+              <a:t>3/23/2026</a:t>
             </a:fld>
             <a:endParaRPr lang="en-US" dirty="0"/>
           </a:p>
@@ -11262,7 +11263,7 @@
           <a:p>
             <a:fld id="{01367C22-F4EA-409B-8211-8EE28F1768FA}" type="datetime1">
               <a:rPr lang="en-US" smtClean="0"/>
-              <a:t>3/18/2026</a:t>
+              <a:t>3/23/2026</a:t>
             </a:fld>
             <a:endParaRPr lang="en-US" dirty="0"/>
           </a:p>
@@ -11557,7 +11558,7 @@
           <a:p>
             <a:fld id="{B3010660-BAD1-44D8-9C23-5C88A1A8F01F}" type="datetime1">
               <a:rPr lang="en-US" smtClean="0"/>
-              <a:t>3/18/2026</a:t>
+              <a:t>3/23/2026</a:t>
             </a:fld>
             <a:endParaRPr lang="en-US" dirty="0"/>
           </a:p>
@@ -11878,7 +11879,7 @@
           <a:p>
             <a:fld id="{EDCF0ECF-ADF6-4A1E-AC47-07B1AF22895C}" type="datetime1">
               <a:rPr lang="en-US" smtClean="0"/>
-              <a:t>3/18/2026</a:t>
+              <a:t>3/23/2026</a:t>
             </a:fld>
             <a:endParaRPr lang="en-US" dirty="0"/>
           </a:p>
@@ -12038,7 +12039,7 @@
           <a:p>
             <a:fld id="{E7285047-D83B-4CBC-B382-99B4652369DA}" type="datetime1">
               <a:rPr lang="en-US" smtClean="0"/>
-              <a:t>3/18/2026</a:t>
+              <a:t>3/23/2026</a:t>
             </a:fld>
             <a:endParaRPr lang="en-US" dirty="0"/>
           </a:p>
@@ -12297,7 +12298,7 @@
           <a:p>
             <a:fld id="{5DA3712D-D7D4-403D-A209-BF5EC4A3587F}" type="datetime1">
               <a:rPr lang="en-US" smtClean="0"/>
-              <a:t>3/18/2026</a:t>
+              <a:t>3/23/2026</a:t>
             </a:fld>
             <a:endParaRPr lang="en-US" dirty="0"/>
           </a:p>
@@ -12759,7 +12760,7 @@
           <a:p>
             <a:fld id="{9861EEC7-BE98-4A95-805B-FF027B01800D}" type="datetime1">
               <a:rPr lang="en-US" smtClean="0"/>
-              <a:t>3/18/2026</a:t>
+              <a:t>3/23/2026</a:t>
             </a:fld>
             <a:endParaRPr lang="en-US" dirty="0"/>
           </a:p>
@@ -13040,7 +13041,7 @@
           <a:p>
             <a:fld id="{7E661689-212A-4C55-AD2C-A83E50F427D0}" type="datetime1">
               <a:rPr lang="en-US" smtClean="0"/>
-              <a:t>3/18/2026</a:t>
+              <a:t>3/23/2026</a:t>
             </a:fld>
             <a:endParaRPr lang="en-US" dirty="0"/>
           </a:p>
@@ -13426,7 +13427,7 @@
           <a:p>
             <a:fld id="{117D9B44-7D28-47E6-9F0A-F47B33759971}" type="datetime1">
               <a:rPr lang="en-US" smtClean="0"/>
-              <a:t>3/18/2026</a:t>
+              <a:t>3/23/2026</a:t>
             </a:fld>
             <a:endParaRPr lang="en-US" dirty="0"/>
           </a:p>
@@ -13812,7 +13813,7 @@
           <a:p>
             <a:fld id="{20496D0C-097B-4988-9331-8881DF7CDB89}" type="datetime1">
               <a:rPr lang="en-US" smtClean="0"/>
-              <a:t>3/18/2026</a:t>
+              <a:t>3/23/2026</a:t>
             </a:fld>
             <a:endParaRPr lang="en-US" dirty="0"/>
           </a:p>
@@ -14081,7 +14082,7 @@
           <a:p>
             <a:fld id="{DE934A9A-2750-4623-9BD8-F6C697020276}" type="datetime1">
               <a:rPr lang="en-US" smtClean="0"/>
-              <a:t>3/18/2026</a:t>
+              <a:t>3/23/2026</a:t>
             </a:fld>
             <a:endParaRPr lang="en-US" dirty="0"/>
           </a:p>
@@ -14481,7 +14482,7 @@
           <a:p>
             <a:fld id="{E442BEA7-1BD7-466C-9FE4-084C8EC3472E}" type="datetime1">
               <a:rPr lang="en-US" smtClean="0"/>
-              <a:t>3/18/2026</a:t>
+              <a:t>3/23/2026</a:t>
             </a:fld>
             <a:endParaRPr lang="en-US" dirty="0"/>
           </a:p>
@@ -14817,7 +14818,7 @@
           <a:p>
             <a:fld id="{0EE36BD2-1276-4645-9FBA-9998723CC05B}" type="datetime1">
               <a:rPr lang="en-US" smtClean="0"/>
-              <a:t>3/18/2026</a:t>
+              <a:t>3/23/2026</a:t>
             </a:fld>
             <a:endParaRPr lang="en-US" dirty="0"/>
           </a:p>
@@ -15254,7 +15255,7 @@
           <a:p>
             <a:fld id="{F1294456-1EEE-4980-941C-4A9E968F86B5}" type="datetime1">
               <a:rPr lang="en-US" smtClean="0"/>
-              <a:t>3/18/2026</a:t>
+              <a:t>3/23/2026</a:t>
             </a:fld>
             <a:endParaRPr lang="en-US" dirty="0"/>
           </a:p>
@@ -15489,7 +15490,7 @@
           <a:p>
             <a:fld id="{B19F9D8F-2068-496E-BBC6-C8FE744C667E}" type="datetime1">
               <a:rPr lang="en-US" smtClean="0"/>
-              <a:t>3/18/2026</a:t>
+              <a:t>3/23/2026</a:t>
             </a:fld>
             <a:endParaRPr lang="en-US" dirty="0"/>
           </a:p>
@@ -15762,7 +15763,7 @@
           <a:p>
             <a:fld id="{704DA27A-3F14-4175-8E3F-E94F1FBE9554}" type="datetime1">
               <a:rPr lang="en-US" smtClean="0"/>
-              <a:t>3/18/2026</a:t>
+              <a:t>3/23/2026</a:t>
             </a:fld>
             <a:endParaRPr lang="en-US" dirty="0"/>
           </a:p>
@@ -16187,7 +16188,7 @@
           <a:p>
             <a:fld id="{F423CB09-86E8-4467-93BF-C8AD813B1CB8}" type="datetime1">
               <a:rPr lang="en-US" smtClean="0"/>
-              <a:t>3/18/2026</a:t>
+              <a:t>3/23/2026</a:t>
             </a:fld>
             <a:endParaRPr lang="en-US" dirty="0"/>
           </a:p>
@@ -16522,7 +16523,7 @@
           <a:p>
             <a:fld id="{914A049B-C345-4C9D-A29E-0E39496BD178}" type="datetime1">
               <a:rPr lang="en-US" smtClean="0"/>
-              <a:t>3/18/2026</a:t>
+              <a:t>3/23/2026</a:t>
             </a:fld>
             <a:endParaRPr lang="en-US" dirty="0"/>
           </a:p>
@@ -16699,7 +16700,7 @@
           <a:p>
             <a:fld id="{CA1B0877-9FC7-4D4A-9954-B78179689751}" type="datetime1">
               <a:rPr lang="en-US" smtClean="0"/>
-              <a:t>3/18/2026</a:t>
+              <a:t>3/23/2026</a:t>
             </a:fld>
             <a:endParaRPr lang="en-US" dirty="0"/>
           </a:p>
@@ -16799,7 +16800,7 @@
           <a:p>
             <a:fld id="{78185C1F-3DC8-41BD-A888-D15090A5BE1C}" type="datetime1">
               <a:rPr lang="en-US" smtClean="0"/>
-              <a:t>3/18/2026</a:t>
+              <a:t>3/23/2026</a:t>
             </a:fld>
             <a:endParaRPr lang="en-US" dirty="0"/>
           </a:p>
@@ -17182,7 +17183,7 @@
           <a:p>
             <a:fld id="{F74847A6-4915-4DCE-9792-3249F7265D8D}" type="datetime1">
               <a:rPr lang="en-US" smtClean="0"/>
-              <a:t>3/18/2026</a:t>
+              <a:t>3/23/2026</a:t>
             </a:fld>
             <a:endParaRPr lang="en-US" dirty="0"/>
           </a:p>
@@ -17476,7 +17477,7 @@
           <a:p>
             <a:fld id="{7B836C08-7E11-4206-8D6F-C5008A7638E7}" type="datetime1">
               <a:rPr lang="en-US" smtClean="0"/>
-              <a:t>3/18/2026</a:t>
+              <a:t>3/23/2026</a:t>
             </a:fld>
             <a:endParaRPr lang="en-US" dirty="0"/>
           </a:p>
@@ -17692,7 +17693,7 @@
           <a:p>
             <a:fld id="{F520C35D-1675-4133-A710-2F97F53C54F7}" type="datetime1">
               <a:rPr lang="en-US" smtClean="0"/>
-              <a:t>3/18/2026</a:t>
+              <a:t>3/23/2026</a:t>
             </a:fld>
             <a:endParaRPr lang="en-US" dirty="0"/>
           </a:p>
@@ -18547,6 +18548,24 @@
           <a:p>
             <a:r>
               <a:rPr lang="en-US" dirty="0"/>
+              <a:t>How to use local database?</a:t>
+            </a:r>
+          </a:p>
+          <a:p>
+            <a:r>
+              <a:rPr lang="en-US" dirty="0"/>
+              <a:t>Functionalities</a:t>
+            </a:r>
+          </a:p>
+          <a:p>
+            <a:r>
+              <a:rPr lang="en-US" dirty="0"/>
+              <a:t>Architecture</a:t>
+            </a:r>
+          </a:p>
+          <a:p>
+            <a:r>
+              <a:rPr lang="en-US" dirty="0"/>
               <a:t>List Page (Post List)</a:t>
             </a:r>
           </a:p>
@@ -19302,7 +19321,7 @@
           <p:cNvPr id="2" name="Title 1">
             <a:extLst>
               <a:ext uri="{FF2B5EF4-FFF2-40B4-BE49-F238E27FC236}">
-                <a16:creationId xmlns:a16="http://schemas.microsoft.com/office/drawing/2014/main" id="{41D64FCB-6AAA-89BF-DDFA-946374D19F3E}"/>
+                <a16:creationId xmlns:a16="http://schemas.microsoft.com/office/drawing/2014/main" id="{6500AD68-FFE4-D86E-EF46-1986A6D0EA91}"/>
               </a:ext>
             </a:extLst>
           </p:cNvPr>
@@ -19320,7 +19339,7 @@
           <a:p>
             <a:r>
               <a:rPr lang="en-US" dirty="0"/>
-              <a:t>architecture</a:t>
+              <a:t>HOW TO USE THE LOCAL DATABASE?</a:t>
             </a:r>
           </a:p>
         </p:txBody>
@@ -19330,7 +19349,7 @@
           <p:cNvPr id="3" name="Content Placeholder 2">
             <a:extLst>
               <a:ext uri="{FF2B5EF4-FFF2-40B4-BE49-F238E27FC236}">
-                <a16:creationId xmlns:a16="http://schemas.microsoft.com/office/drawing/2014/main" id="{5F1B830B-1C0A-E520-9C86-EC52FF8C01E6}"/>
+                <a16:creationId xmlns:a16="http://schemas.microsoft.com/office/drawing/2014/main" id="{18C80AD6-9834-37BE-3A4C-B596B7722DD8}"/>
               </a:ext>
             </a:extLst>
           </p:cNvPr>
@@ -19341,103 +19360,93 @@
             <p:ph idx="1"/>
           </p:nvPr>
         </p:nvSpPr>
-        <p:spPr>
-          <a:xfrm>
-            <a:off x="581192" y="2180496"/>
-            <a:ext cx="11029615" cy="3975348"/>
-          </a:xfrm>
-        </p:spPr>
+        <p:spPr/>
         <p:txBody>
           <a:bodyPr anchor="t"/>
           <a:lstStyle/>
           <a:p>
             <a:r>
               <a:rPr lang="en-US" dirty="0"/>
-              <a:t>Pages</a:t>
+              <a:t>In api.js change </a:t>
+            </a:r>
+            <a:r>
+              <a:rPr lang="it-IT" dirty="0"/>
+              <a:t>API_BASE_URL to "http://localhost:3000";</a:t>
+            </a:r>
+          </a:p>
+          <a:p>
+            <a:endParaRPr lang="en-US" dirty="0"/>
+          </a:p>
+          <a:p>
+            <a:r>
+              <a:rPr lang="en-US" dirty="0"/>
+              <a:t>Once downloaded the project, in the folder:</a:t>
             </a:r>
           </a:p>
           <a:p>
             <a:pPr lvl="1"/>
             <a:r>
+              <a:rPr lang="en-US" dirty="0" err="1"/>
+              <a:t>npm</a:t>
+            </a:r>
+            <a:r>
               <a:rPr lang="en-US" dirty="0"/>
-              <a:t>Index.html </a:t>
-            </a:r>
-            <a:r>
-              <a:rPr lang="en-US" dirty="0">
-                <a:sym typeface="Wingdings" panose="05000000000000000000" pitchFamily="2" charset="2"/>
-              </a:rPr>
-              <a:t> Posts lists with pagination</a:t>
+              <a:t> install</a:t>
             </a:r>
           </a:p>
           <a:p>
             <a:pPr lvl="1"/>
             <a:r>
-              <a:rPr lang="en-US" dirty="0">
-                <a:sym typeface="Wingdings" panose="05000000000000000000" pitchFamily="2" charset="2"/>
-              </a:rPr>
-              <a:t>Post.html  Post details and comments</a:t>
+              <a:rPr lang="en-US" dirty="0" err="1"/>
+              <a:t>npm</a:t>
+            </a:r>
+            <a:r>
+              <a:rPr lang="en-US" dirty="0"/>
+              <a:t> start</a:t>
             </a:r>
           </a:p>
           <a:p>
             <a:pPr lvl="1"/>
-            <a:r>
-              <a:rPr lang="en-US" dirty="0">
-                <a:sym typeface="Wingdings" panose="05000000000000000000" pitchFamily="2" charset="2"/>
-              </a:rPr>
-              <a:t>Form.html  Shared for creating and editing posts</a:t>
-            </a:r>
-          </a:p>
-          <a:p>
-            <a:pPr lvl="1"/>
-            <a:endParaRPr lang="en-US" dirty="0">
-              <a:sym typeface="Wingdings" panose="05000000000000000000" pitchFamily="2" charset="2"/>
-            </a:endParaRPr>
-          </a:p>
-          <a:p>
-            <a:r>
-              <a:rPr lang="en-US" dirty="0">
-                <a:sym typeface="Wingdings" panose="05000000000000000000" pitchFamily="2" charset="2"/>
-              </a:rPr>
-              <a:t>JavaScript Modules</a:t>
-            </a:r>
-          </a:p>
-          <a:p>
-            <a:pPr lvl="1"/>
-            <a:r>
-              <a:rPr lang="en-US" dirty="0">
-                <a:sym typeface="Wingdings" panose="05000000000000000000" pitchFamily="2" charset="2"/>
-              </a:rPr>
-              <a:t>Api.js  handles all the HTTP requests</a:t>
-            </a:r>
-          </a:p>
-          <a:p>
-            <a:pPr lvl="1"/>
-            <a:r>
-              <a:rPr lang="en-US" dirty="0">
-                <a:sym typeface="Wingdings" panose="05000000000000000000" pitchFamily="2" charset="2"/>
-              </a:rPr>
-              <a:t>Main.js  manages post listing and pagination</a:t>
-            </a:r>
-          </a:p>
-          <a:p>
-            <a:pPr lvl="1"/>
-            <a:r>
-              <a:rPr lang="en-US" dirty="0">
-                <a:sym typeface="Wingdings" panose="05000000000000000000" pitchFamily="2" charset="2"/>
-              </a:rPr>
-              <a:t>Post.js  handles post details and comment logic</a:t>
-            </a:r>
-          </a:p>
-          <a:p>
-            <a:pPr lvl="1"/>
-            <a:r>
-              <a:rPr lang="en-US" dirty="0">
-                <a:sym typeface="Wingdings" panose="05000000000000000000" pitchFamily="2" charset="2"/>
-              </a:rPr>
-              <a:t>Form.js  handles post creation and editing</a:t>
-            </a:r>
             <a:endParaRPr lang="en-US" dirty="0"/>
           </a:p>
+          <a:p>
+            <a:r>
+              <a:rPr lang="en-US" dirty="0"/>
+              <a:t>Added </a:t>
+            </a:r>
+            <a:r>
+              <a:rPr lang="en-US" dirty="0" err="1"/>
+              <a:t>package.json</a:t>
+            </a:r>
+            <a:r>
+              <a:rPr lang="en-US" dirty="0"/>
+              <a:t> (script inside: </a:t>
+            </a:r>
+            <a:r>
+              <a:rPr lang="en-US" dirty="0" err="1"/>
+              <a:t>npx</a:t>
+            </a:r>
+            <a:r>
+              <a:rPr lang="en-US" dirty="0"/>
+              <a:t> </a:t>
+            </a:r>
+            <a:r>
+              <a:rPr lang="en-US" dirty="0" err="1"/>
+              <a:t>json</a:t>
+            </a:r>
+            <a:r>
+              <a:rPr lang="en-US" dirty="0"/>
+              <a:t>-server --watch </a:t>
+            </a:r>
+            <a:r>
+              <a:rPr lang="en-US" dirty="0" err="1"/>
+              <a:t>db.json</a:t>
+            </a:r>
+            <a:r>
+              <a:rPr lang="en-US" dirty="0"/>
+              <a:t> --port 3000) and package-lock to made the commands easier</a:t>
+            </a:r>
+          </a:p>
         </p:txBody>
       </p:sp>
       <p:sp>
@@ -19445,7 +19454,7 @@
           <p:cNvPr id="4" name="Slide Number Placeholder 3">
             <a:extLst>
               <a:ext uri="{FF2B5EF4-FFF2-40B4-BE49-F238E27FC236}">
-                <a16:creationId xmlns:a16="http://schemas.microsoft.com/office/drawing/2014/main" id="{55151587-0046-6B10-4C09-9CA7AF12B9F2}"/>
+                <a16:creationId xmlns:a16="http://schemas.microsoft.com/office/drawing/2014/main" id="{E993091B-B972-E553-61AF-784B6B7CB2A6}"/>
               </a:ext>
             </a:extLst>
           </p:cNvPr>
@@ -19472,7 +19481,7 @@
     </p:spTree>
     <p:extLst>
       <p:ext uri="{BB962C8B-B14F-4D97-AF65-F5344CB8AC3E}">
-        <p14:creationId xmlns:p14="http://schemas.microsoft.com/office/powerpoint/2010/main" val="443608448"/>
+        <p14:creationId xmlns:p14="http://schemas.microsoft.com/office/powerpoint/2010/main" val="530182429"/>
       </p:ext>
     </p:extLst>
   </p:cSld>
@@ -19504,7 +19513,7 @@
           <p:cNvPr id="2" name="Title 1">
             <a:extLst>
               <a:ext uri="{FF2B5EF4-FFF2-40B4-BE49-F238E27FC236}">
-                <a16:creationId xmlns:a16="http://schemas.microsoft.com/office/drawing/2014/main" id="{B3F04123-B8CF-DB72-70A8-68B3F8339544}"/>
+                <a16:creationId xmlns:a16="http://schemas.microsoft.com/office/drawing/2014/main" id="{41D64FCB-6AAA-89BF-DDFA-946374D19F3E}"/>
               </a:ext>
             </a:extLst>
           </p:cNvPr>
@@ -19522,7 +19531,7 @@
           <a:p>
             <a:r>
               <a:rPr lang="en-US" dirty="0"/>
-              <a:t>List page (post list)</a:t>
+              <a:t>architecture</a:t>
             </a:r>
           </a:p>
         </p:txBody>
@@ -19532,7 +19541,7 @@
           <p:cNvPr id="3" name="Content Placeholder 2">
             <a:extLst>
               <a:ext uri="{FF2B5EF4-FFF2-40B4-BE49-F238E27FC236}">
-                <a16:creationId xmlns:a16="http://schemas.microsoft.com/office/drawing/2014/main" id="{9DD857B2-0E06-156C-7F1D-35FF20D3328D}"/>
+                <a16:creationId xmlns:a16="http://schemas.microsoft.com/office/drawing/2014/main" id="{5F1B830B-1C0A-E520-9C86-EC52FF8C01E6}"/>
               </a:ext>
             </a:extLst>
           </p:cNvPr>
@@ -19546,37 +19555,29 @@
         <p:spPr>
           <a:xfrm>
             <a:off x="581192" y="2180496"/>
-            <a:ext cx="11029615" cy="4339176"/>
+            <a:ext cx="11029615" cy="3975348"/>
           </a:xfrm>
         </p:spPr>
         <p:txBody>
-          <a:bodyPr anchor="t">
-            <a:normAutofit fontScale="92500" lnSpcReduction="20000"/>
-          </a:bodyPr>
+          <a:bodyPr anchor="t"/>
           <a:lstStyle/>
           <a:p>
             <a:r>
-              <a:rPr lang="en-US" b="1" dirty="0"/>
-              <a:t>URL: index.html</a:t>
-            </a:r>
-          </a:p>
-          <a:p>
-            <a:r>
-              <a:rPr lang="en-US" b="1" dirty="0"/>
-              <a:t>UI components</a:t>
+              <a:rPr lang="en-US" dirty="0"/>
+              <a:t>Pages</a:t>
             </a:r>
           </a:p>
           <a:p>
             <a:pPr lvl="1"/>
             <a:r>
               <a:rPr lang="en-US" dirty="0"/>
-              <a:t>Post table </a:t>
+              <a:t>Index.html </a:t>
             </a:r>
             <a:r>
               <a:rPr lang="en-US" dirty="0">
                 <a:sym typeface="Wingdings" panose="05000000000000000000" pitchFamily="2" charset="2"/>
               </a:rPr>
-              <a:t> displays list of posts (ID, title, username)</a:t>
+              <a:t> Posts lists with pagination</a:t>
             </a:r>
           </a:p>
           <a:p>
@@ -19585,7 +19586,7 @@
               <a:rPr lang="en-US" dirty="0">
                 <a:sym typeface="Wingdings" panose="05000000000000000000" pitchFamily="2" charset="2"/>
               </a:rPr>
-              <a:t>Post Title Link  clickable opens the post detail page</a:t>
+              <a:t>Post.html  Post details and comments</a:t>
             </a:r>
           </a:p>
           <a:p>
@@ -19594,24 +19595,21 @@
               <a:rPr lang="en-US" dirty="0">
                 <a:sym typeface="Wingdings" panose="05000000000000000000" pitchFamily="2" charset="2"/>
               </a:rPr>
-              <a:t>Create Post Button  navigates to post creation page</a:t>
+              <a:t>Form.html  Shared for creating and editing posts</a:t>
             </a:r>
           </a:p>
           <a:p>
             <a:pPr lvl="1"/>
+            <a:endParaRPr lang="en-US" dirty="0">
+              <a:sym typeface="Wingdings" panose="05000000000000000000" pitchFamily="2" charset="2"/>
+            </a:endParaRPr>
+          </a:p>
+          <a:p>
             <a:r>
               <a:rPr lang="en-US" dirty="0">
                 <a:sym typeface="Wingdings" panose="05000000000000000000" pitchFamily="2" charset="2"/>
               </a:rPr>
-              <a:t>Pagination controls  navigation previous/next page</a:t>
-            </a:r>
-          </a:p>
-          <a:p>
-            <a:r>
-              <a:rPr lang="en-US" b="1" dirty="0">
-                <a:sym typeface="Wingdings" panose="05000000000000000000" pitchFamily="2" charset="2"/>
-              </a:rPr>
-              <a:t>API used</a:t>
+              <a:t>JavaScript Modules</a:t>
             </a:r>
           </a:p>
           <a:p>
@@ -19620,7 +19618,7 @@
               <a:rPr lang="en-US" dirty="0">
                 <a:sym typeface="Wingdings" panose="05000000000000000000" pitchFamily="2" charset="2"/>
               </a:rPr>
-              <a:t>GET /posts  retrieve posts</a:t>
+              <a:t>Api.js  handles all the HTTP requests</a:t>
             </a:r>
           </a:p>
           <a:p>
@@ -19629,15 +19627,7 @@
               <a:rPr lang="en-US" dirty="0">
                 <a:sym typeface="Wingdings" panose="05000000000000000000" pitchFamily="2" charset="2"/>
               </a:rPr>
-              <a:t>GET /users  retrieve user information</a:t>
-            </a:r>
-          </a:p>
-          <a:p>
-            <a:r>
-              <a:rPr lang="en-US" b="1" dirty="0">
-                <a:sym typeface="Wingdings" panose="05000000000000000000" pitchFamily="2" charset="2"/>
-              </a:rPr>
-              <a:t>User actions</a:t>
+              <a:t>Main.js  manages post listing and pagination</a:t>
             </a:r>
           </a:p>
           <a:p>
@@ -19646,7 +19636,7 @@
               <a:rPr lang="en-US" dirty="0">
                 <a:sym typeface="Wingdings" panose="05000000000000000000" pitchFamily="2" charset="2"/>
               </a:rPr>
-              <a:t>Click post title  opens post detail page</a:t>
+              <a:t>Post.js  handles post details and comment logic</a:t>
             </a:r>
           </a:p>
           <a:p>
@@ -19655,20 +19645,7 @@
               <a:rPr lang="en-US" dirty="0">
                 <a:sym typeface="Wingdings" panose="05000000000000000000" pitchFamily="2" charset="2"/>
               </a:rPr>
-              <a:t>Click create post  opens create post page</a:t>
-            </a:r>
-          </a:p>
-          <a:p>
-            <a:pPr lvl="1"/>
-            <a:r>
-              <a:rPr lang="en-US" dirty="0"/>
-              <a:t>Click next/previous </a:t>
-            </a:r>
-            <a:r>
-              <a:rPr lang="en-US" dirty="0">
-                <a:sym typeface="Wingdings" panose="05000000000000000000" pitchFamily="2" charset="2"/>
-              </a:rPr>
-              <a:t> changes page of posts </a:t>
+              <a:t>Form.js  handles post creation and editing</a:t>
             </a:r>
             <a:endParaRPr lang="en-US" dirty="0"/>
           </a:p>
@@ -19679,7 +19656,7 @@
           <p:cNvPr id="4" name="Slide Number Placeholder 3">
             <a:extLst>
               <a:ext uri="{FF2B5EF4-FFF2-40B4-BE49-F238E27FC236}">
-                <a16:creationId xmlns:a16="http://schemas.microsoft.com/office/drawing/2014/main" id="{E228F799-64A5-E7F9-C874-D0BD683B9759}"/>
+                <a16:creationId xmlns:a16="http://schemas.microsoft.com/office/drawing/2014/main" id="{55151587-0046-6B10-4C09-9CA7AF12B9F2}"/>
               </a:ext>
             </a:extLst>
           </p:cNvPr>
@@ -19703,273 +19680,10 @@
           </a:p>
         </p:txBody>
       </p:sp>
-      <p:sp>
-        <p:nvSpPr>
-          <p:cNvPr id="7" name="Rectangle 6">
-            <a:extLst>
-              <a:ext uri="{FF2B5EF4-FFF2-40B4-BE49-F238E27FC236}">
-                <a16:creationId xmlns:a16="http://schemas.microsoft.com/office/drawing/2014/main" id="{C7B705FB-FC8D-96DE-D908-BA035E7C1C9A}"/>
-              </a:ext>
-            </a:extLst>
-          </p:cNvPr>
-          <p:cNvSpPr/>
-          <p:nvPr/>
-        </p:nvSpPr>
-        <p:spPr>
-          <a:xfrm>
-            <a:off x="6867144" y="2404872"/>
-            <a:ext cx="3547872" cy="3310128"/>
-          </a:xfrm>
-          <a:prstGeom prst="rect">
-            <a:avLst/>
-          </a:prstGeom>
-        </p:spPr>
-        <p:style>
-          <a:lnRef idx="2">
-            <a:schemeClr val="accent1"/>
-          </a:lnRef>
-          <a:fillRef idx="1">
-            <a:schemeClr val="lt1"/>
-          </a:fillRef>
-          <a:effectRef idx="0">
-            <a:schemeClr val="accent1"/>
-          </a:effectRef>
-          <a:fontRef idx="minor">
-            <a:schemeClr val="dk1"/>
-          </a:fontRef>
-        </p:style>
-        <p:txBody>
-          <a:bodyPr rtlCol="0" anchor="t"/>
-          <a:lstStyle/>
-          <a:p>
-            <a:pPr algn="ctr"/>
-            <a:r>
-              <a:rPr lang="en-US" dirty="0"/>
-              <a:t>MESSAGE BOARD</a:t>
-            </a:r>
-          </a:p>
-        </p:txBody>
-      </p:sp>
-      <p:sp>
-        <p:nvSpPr>
-          <p:cNvPr id="8" name="Rectangle 7">
-            <a:extLst>
-              <a:ext uri="{FF2B5EF4-FFF2-40B4-BE49-F238E27FC236}">
-                <a16:creationId xmlns:a16="http://schemas.microsoft.com/office/drawing/2014/main" id="{5DE1A25C-3642-713C-06D9-9541FBE2FB46}"/>
-              </a:ext>
-            </a:extLst>
-          </p:cNvPr>
-          <p:cNvSpPr/>
-          <p:nvPr/>
-        </p:nvSpPr>
-        <p:spPr>
-          <a:xfrm>
-            <a:off x="7028688" y="2804160"/>
-            <a:ext cx="1456944" cy="359664"/>
-          </a:xfrm>
-          <a:prstGeom prst="rect">
-            <a:avLst/>
-          </a:prstGeom>
-        </p:spPr>
-        <p:style>
-          <a:lnRef idx="2">
-            <a:schemeClr val="accent6"/>
-          </a:lnRef>
-          <a:fillRef idx="1">
-            <a:schemeClr val="lt1"/>
-          </a:fillRef>
-          <a:effectRef idx="0">
-            <a:schemeClr val="accent6"/>
-          </a:effectRef>
-          <a:fontRef idx="minor">
-            <a:schemeClr val="dk1"/>
-          </a:fontRef>
-        </p:style>
-        <p:txBody>
-          <a:bodyPr rtlCol="0" anchor="t"/>
-          <a:lstStyle/>
-          <a:p>
-            <a:pPr algn="ctr"/>
-            <a:r>
-              <a:rPr lang="en-US" dirty="0"/>
-              <a:t>Create post</a:t>
-            </a:r>
-          </a:p>
-        </p:txBody>
-      </p:sp>
-      <p:sp>
-        <p:nvSpPr>
-          <p:cNvPr id="9" name="Rectangle 8">
-            <a:extLst>
-              <a:ext uri="{FF2B5EF4-FFF2-40B4-BE49-F238E27FC236}">
-                <a16:creationId xmlns:a16="http://schemas.microsoft.com/office/drawing/2014/main" id="{59E97641-0A9F-1646-3262-BDDF79279BDA}"/>
-              </a:ext>
-            </a:extLst>
-          </p:cNvPr>
-          <p:cNvSpPr/>
-          <p:nvPr/>
-        </p:nvSpPr>
-        <p:spPr>
-          <a:xfrm>
-            <a:off x="7028688" y="3320796"/>
-            <a:ext cx="3212592" cy="1478280"/>
-          </a:xfrm>
-          <a:prstGeom prst="rect">
-            <a:avLst/>
-          </a:prstGeom>
-        </p:spPr>
-        <p:style>
-          <a:lnRef idx="2">
-            <a:schemeClr val="accent4"/>
-          </a:lnRef>
-          <a:fillRef idx="1">
-            <a:schemeClr val="lt1"/>
-          </a:fillRef>
-          <a:effectRef idx="0">
-            <a:schemeClr val="accent4"/>
-          </a:effectRef>
-          <a:fontRef idx="minor">
-            <a:schemeClr val="dk1"/>
-          </a:fontRef>
-        </p:style>
-        <p:txBody>
-          <a:bodyPr rtlCol="0" anchor="t"/>
-          <a:lstStyle/>
-          <a:p>
-            <a:pPr algn="ctr"/>
-            <a:r>
-              <a:rPr lang="en-US" dirty="0"/>
-              <a:t>ID – title – username </a:t>
-            </a:r>
-          </a:p>
-          <a:p>
-            <a:pPr algn="ctr"/>
-            <a:r>
-              <a:rPr lang="en-US" dirty="0"/>
-              <a:t>.</a:t>
-            </a:r>
-          </a:p>
-          <a:p>
-            <a:pPr algn="ctr"/>
-            <a:r>
-              <a:rPr lang="en-US" dirty="0"/>
-              <a:t>.</a:t>
-            </a:r>
-          </a:p>
-          <a:p>
-            <a:pPr algn="ctr"/>
-            <a:r>
-              <a:rPr lang="en-US" dirty="0"/>
-              <a:t>.</a:t>
-            </a:r>
-          </a:p>
-          <a:p>
-            <a:pPr algn="ctr"/>
-            <a:r>
-              <a:rPr lang="en-US" dirty="0"/>
-              <a:t>.</a:t>
-            </a:r>
-          </a:p>
-        </p:txBody>
-      </p:sp>
-      <p:sp>
-        <p:nvSpPr>
-          <p:cNvPr id="10" name="Rectangle 9">
-            <a:extLst>
-              <a:ext uri="{FF2B5EF4-FFF2-40B4-BE49-F238E27FC236}">
-                <a16:creationId xmlns:a16="http://schemas.microsoft.com/office/drawing/2014/main" id="{A0437D79-E130-2296-42C4-919C6F41B6F8}"/>
-              </a:ext>
-            </a:extLst>
-          </p:cNvPr>
-          <p:cNvSpPr/>
-          <p:nvPr/>
-        </p:nvSpPr>
-        <p:spPr>
-          <a:xfrm>
-            <a:off x="7028688" y="4956048"/>
-            <a:ext cx="1456944" cy="359664"/>
-          </a:xfrm>
-          <a:prstGeom prst="rect">
-            <a:avLst/>
-          </a:prstGeom>
-        </p:spPr>
-        <p:style>
-          <a:lnRef idx="2">
-            <a:schemeClr val="accent6"/>
-          </a:lnRef>
-          <a:fillRef idx="1">
-            <a:schemeClr val="lt1"/>
-          </a:fillRef>
-          <a:effectRef idx="0">
-            <a:schemeClr val="accent6"/>
-          </a:effectRef>
-          <a:fontRef idx="minor">
-            <a:schemeClr val="dk1"/>
-          </a:fontRef>
-        </p:style>
-        <p:txBody>
-          <a:bodyPr rtlCol="0" anchor="t"/>
-          <a:lstStyle/>
-          <a:p>
-            <a:pPr algn="ctr"/>
-            <a:r>
-              <a:rPr lang="en-US" dirty="0"/>
-              <a:t>Prev post</a:t>
-            </a:r>
-          </a:p>
-        </p:txBody>
-      </p:sp>
-      <p:sp>
-        <p:nvSpPr>
-          <p:cNvPr id="11" name="Rectangle 10">
-            <a:extLst>
-              <a:ext uri="{FF2B5EF4-FFF2-40B4-BE49-F238E27FC236}">
-                <a16:creationId xmlns:a16="http://schemas.microsoft.com/office/drawing/2014/main" id="{B3F33C73-2C9D-3EC0-D2CE-97FFB849CBF5}"/>
-              </a:ext>
-            </a:extLst>
-          </p:cNvPr>
-          <p:cNvSpPr/>
-          <p:nvPr/>
-        </p:nvSpPr>
-        <p:spPr>
-          <a:xfrm>
-            <a:off x="8721852" y="4956048"/>
-            <a:ext cx="1456944" cy="359664"/>
-          </a:xfrm>
-          <a:prstGeom prst="rect">
-            <a:avLst/>
-          </a:prstGeom>
-        </p:spPr>
-        <p:style>
-          <a:lnRef idx="2">
-            <a:schemeClr val="accent6"/>
-          </a:lnRef>
-          <a:fillRef idx="1">
-            <a:schemeClr val="lt1"/>
-          </a:fillRef>
-          <a:effectRef idx="0">
-            <a:schemeClr val="accent6"/>
-          </a:effectRef>
-          <a:fontRef idx="minor">
-            <a:schemeClr val="dk1"/>
-          </a:fontRef>
-        </p:style>
-        <p:txBody>
-          <a:bodyPr rtlCol="0" anchor="t"/>
-          <a:lstStyle/>
-          <a:p>
-            <a:pPr algn="ctr"/>
-            <a:r>
-              <a:rPr lang="en-US" dirty="0"/>
-              <a:t>Next post</a:t>
-            </a:r>
-          </a:p>
-        </p:txBody>
-      </p:sp>
     </p:spTree>
     <p:extLst>
       <p:ext uri="{BB962C8B-B14F-4D97-AF65-F5344CB8AC3E}">
-        <p14:creationId xmlns:p14="http://schemas.microsoft.com/office/powerpoint/2010/main" val="845911360"/>
+        <p14:creationId xmlns:p14="http://schemas.microsoft.com/office/powerpoint/2010/main" val="443608448"/>
       </p:ext>
     </p:extLst>
   </p:cSld>
@@ -20001,7 +19715,7 @@
           <p:cNvPr id="2" name="Title 1">
             <a:extLst>
               <a:ext uri="{FF2B5EF4-FFF2-40B4-BE49-F238E27FC236}">
-                <a16:creationId xmlns:a16="http://schemas.microsoft.com/office/drawing/2014/main" id="{DAE49D1C-DA68-1367-2688-824F791CB838}"/>
+                <a16:creationId xmlns:a16="http://schemas.microsoft.com/office/drawing/2014/main" id="{B3F04123-B8CF-DB72-70A8-68B3F8339544}"/>
               </a:ext>
             </a:extLst>
           </p:cNvPr>
@@ -20019,8 +19733,155 @@
           <a:p>
             <a:r>
               <a:rPr lang="en-US" dirty="0"/>
-              <a:t>Post detail page</a:t>
-            </a:r>
+              <a:t>List page (post list)</a:t>
+            </a:r>
+          </a:p>
+        </p:txBody>
+      </p:sp>
+      <p:sp>
+        <p:nvSpPr>
+          <p:cNvPr id="3" name="Content Placeholder 2">
+            <a:extLst>
+              <a:ext uri="{FF2B5EF4-FFF2-40B4-BE49-F238E27FC236}">
+                <a16:creationId xmlns:a16="http://schemas.microsoft.com/office/drawing/2014/main" id="{9DD857B2-0E06-156C-7F1D-35FF20D3328D}"/>
+              </a:ext>
+            </a:extLst>
+          </p:cNvPr>
+          <p:cNvSpPr>
+            <a:spLocks noGrp="1"/>
+          </p:cNvSpPr>
+          <p:nvPr>
+            <p:ph idx="1"/>
+          </p:nvPr>
+        </p:nvSpPr>
+        <p:spPr>
+          <a:xfrm>
+            <a:off x="581192" y="2180496"/>
+            <a:ext cx="11029615" cy="4339176"/>
+          </a:xfrm>
+        </p:spPr>
+        <p:txBody>
+          <a:bodyPr anchor="t">
+            <a:normAutofit fontScale="92500" lnSpcReduction="20000"/>
+          </a:bodyPr>
+          <a:lstStyle/>
+          <a:p>
+            <a:r>
+              <a:rPr lang="en-US" b="1" dirty="0"/>
+              <a:t>URL: index.html</a:t>
+            </a:r>
+          </a:p>
+          <a:p>
+            <a:r>
+              <a:rPr lang="en-US" b="1" dirty="0"/>
+              <a:t>UI components</a:t>
+            </a:r>
+          </a:p>
+          <a:p>
+            <a:pPr lvl="1"/>
+            <a:r>
+              <a:rPr lang="en-US" dirty="0"/>
+              <a:t>Post table </a:t>
+            </a:r>
+            <a:r>
+              <a:rPr lang="en-US" dirty="0">
+                <a:sym typeface="Wingdings" panose="05000000000000000000" pitchFamily="2" charset="2"/>
+              </a:rPr>
+              <a:t> displays list of posts (ID, title, username)</a:t>
+            </a:r>
+          </a:p>
+          <a:p>
+            <a:pPr lvl="1"/>
+            <a:r>
+              <a:rPr lang="en-US" dirty="0">
+                <a:sym typeface="Wingdings" panose="05000000000000000000" pitchFamily="2" charset="2"/>
+              </a:rPr>
+              <a:t>Post Title Link  clickable opens the post detail page</a:t>
+            </a:r>
+          </a:p>
+          <a:p>
+            <a:pPr lvl="1"/>
+            <a:r>
+              <a:rPr lang="en-US" dirty="0">
+                <a:sym typeface="Wingdings" panose="05000000000000000000" pitchFamily="2" charset="2"/>
+              </a:rPr>
+              <a:t>Create Post Button  navigates to post creation page</a:t>
+            </a:r>
+          </a:p>
+          <a:p>
+            <a:pPr lvl="1"/>
+            <a:r>
+              <a:rPr lang="en-US" dirty="0">
+                <a:sym typeface="Wingdings" panose="05000000000000000000" pitchFamily="2" charset="2"/>
+              </a:rPr>
+              <a:t>Pagination controls  navigation previous/next page</a:t>
+            </a:r>
+          </a:p>
+          <a:p>
+            <a:r>
+              <a:rPr lang="en-US" b="1" dirty="0">
+                <a:sym typeface="Wingdings" panose="05000000000000000000" pitchFamily="2" charset="2"/>
+              </a:rPr>
+              <a:t>API used</a:t>
+            </a:r>
+          </a:p>
+          <a:p>
+            <a:pPr lvl="1"/>
+            <a:r>
+              <a:rPr lang="en-US" dirty="0">
+                <a:sym typeface="Wingdings" panose="05000000000000000000" pitchFamily="2" charset="2"/>
+              </a:rPr>
+              <a:t>GET /posts  retrieve posts</a:t>
+            </a:r>
+          </a:p>
+          <a:p>
+            <a:pPr lvl="1"/>
+            <a:r>
+              <a:rPr lang="en-US" dirty="0">
+                <a:sym typeface="Wingdings" panose="05000000000000000000" pitchFamily="2" charset="2"/>
+              </a:rPr>
+              <a:t>GET /users  retrieve user information</a:t>
+            </a:r>
+          </a:p>
+          <a:p>
+            <a:r>
+              <a:rPr lang="en-US" b="1" dirty="0">
+                <a:sym typeface="Wingdings" panose="05000000000000000000" pitchFamily="2" charset="2"/>
+              </a:rPr>
+              <a:t>User actions</a:t>
+            </a:r>
+          </a:p>
+          <a:p>
+            <a:pPr lvl="1"/>
+            <a:r>
+              <a:rPr lang="en-US" dirty="0">
+                <a:sym typeface="Wingdings" panose="05000000000000000000" pitchFamily="2" charset="2"/>
+              </a:rPr>
+              <a:t>Click post title  opens post detail page</a:t>
+            </a:r>
+          </a:p>
+          <a:p>
+            <a:pPr lvl="1"/>
+            <a:r>
+              <a:rPr lang="en-US" dirty="0">
+                <a:sym typeface="Wingdings" panose="05000000000000000000" pitchFamily="2" charset="2"/>
+              </a:rPr>
+              <a:t>Click create post  opens create post page</a:t>
+            </a:r>
+          </a:p>
+          <a:p>
+            <a:pPr lvl="1"/>
+            <a:r>
+              <a:rPr lang="en-US" dirty="0"/>
+              <a:t>Click next/previous </a:t>
+            </a:r>
+            <a:r>
+              <a:rPr lang="en-US" dirty="0">
+                <a:sym typeface="Wingdings" panose="05000000000000000000" pitchFamily="2" charset="2"/>
+              </a:rPr>
+              <a:t> changes page of posts </a:t>
+            </a:r>
+            <a:endParaRPr lang="en-US" dirty="0"/>
           </a:p>
         </p:txBody>
       </p:sp>
@@ -20029,7 +19890,7 @@
           <p:cNvPr id="4" name="Slide Number Placeholder 3">
             <a:extLst>
               <a:ext uri="{FF2B5EF4-FFF2-40B4-BE49-F238E27FC236}">
-                <a16:creationId xmlns:a16="http://schemas.microsoft.com/office/drawing/2014/main" id="{918CF089-E2AA-B8D6-3446-E17A9104FD5E}"/>
+                <a16:creationId xmlns:a16="http://schemas.microsoft.com/office/drawing/2014/main" id="{E228F799-64A5-E7F9-C874-D0BD683B9759}"/>
               </a:ext>
             </a:extLst>
           </p:cNvPr>
@@ -20048,6 +19909,356 @@
             <a:fld id="{84C450F2-3BB4-4AE4-8A35-A9D7AEA4C850}" type="slidenum">
               <a:rPr lang="en-US" smtClean="0"/>
               <a:t>6</a:t>
+            </a:fld>
+            <a:endParaRPr lang="en-US" dirty="0"/>
+          </a:p>
+        </p:txBody>
+      </p:sp>
+      <p:sp>
+        <p:nvSpPr>
+          <p:cNvPr id="7" name="Rectangle 6">
+            <a:extLst>
+              <a:ext uri="{FF2B5EF4-FFF2-40B4-BE49-F238E27FC236}">
+                <a16:creationId xmlns:a16="http://schemas.microsoft.com/office/drawing/2014/main" id="{C7B705FB-FC8D-96DE-D908-BA035E7C1C9A}"/>
+              </a:ext>
+            </a:extLst>
+          </p:cNvPr>
+          <p:cNvSpPr/>
+          <p:nvPr/>
+        </p:nvSpPr>
+        <p:spPr>
+          <a:xfrm>
+            <a:off x="6867144" y="2404872"/>
+            <a:ext cx="3547872" cy="3310128"/>
+          </a:xfrm>
+          <a:prstGeom prst="rect">
+            <a:avLst/>
+          </a:prstGeom>
+        </p:spPr>
+        <p:style>
+          <a:lnRef idx="2">
+            <a:schemeClr val="accent1"/>
+          </a:lnRef>
+          <a:fillRef idx="1">
+            <a:schemeClr val="lt1"/>
+          </a:fillRef>
+          <a:effectRef idx="0">
+            <a:schemeClr val="accent1"/>
+          </a:effectRef>
+          <a:fontRef idx="minor">
+            <a:schemeClr val="dk1"/>
+          </a:fontRef>
+        </p:style>
+        <p:txBody>
+          <a:bodyPr rtlCol="0" anchor="t"/>
+          <a:lstStyle/>
+          <a:p>
+            <a:pPr algn="ctr"/>
+            <a:r>
+              <a:rPr lang="en-US" dirty="0"/>
+              <a:t>MESSAGE BOARD</a:t>
+            </a:r>
+          </a:p>
+        </p:txBody>
+      </p:sp>
+      <p:sp>
+        <p:nvSpPr>
+          <p:cNvPr id="8" name="Rectangle 7">
+            <a:extLst>
+              <a:ext uri="{FF2B5EF4-FFF2-40B4-BE49-F238E27FC236}">
+                <a16:creationId xmlns:a16="http://schemas.microsoft.com/office/drawing/2014/main" id="{5DE1A25C-3642-713C-06D9-9541FBE2FB46}"/>
+              </a:ext>
+            </a:extLst>
+          </p:cNvPr>
+          <p:cNvSpPr/>
+          <p:nvPr/>
+        </p:nvSpPr>
+        <p:spPr>
+          <a:xfrm>
+            <a:off x="7028688" y="2804160"/>
+            <a:ext cx="1456944" cy="359664"/>
+          </a:xfrm>
+          <a:prstGeom prst="rect">
+            <a:avLst/>
+          </a:prstGeom>
+        </p:spPr>
+        <p:style>
+          <a:lnRef idx="2">
+            <a:schemeClr val="accent6"/>
+          </a:lnRef>
+          <a:fillRef idx="1">
+            <a:schemeClr val="lt1"/>
+          </a:fillRef>
+          <a:effectRef idx="0">
+            <a:schemeClr val="accent6"/>
+          </a:effectRef>
+          <a:fontRef idx="minor">
+            <a:schemeClr val="dk1"/>
+          </a:fontRef>
+        </p:style>
+        <p:txBody>
+          <a:bodyPr rtlCol="0" anchor="t"/>
+          <a:lstStyle/>
+          <a:p>
+            <a:pPr algn="ctr"/>
+            <a:r>
+              <a:rPr lang="en-US" dirty="0"/>
+              <a:t>Create post</a:t>
+            </a:r>
+          </a:p>
+        </p:txBody>
+      </p:sp>
+      <p:sp>
+        <p:nvSpPr>
+          <p:cNvPr id="9" name="Rectangle 8">
+            <a:extLst>
+              <a:ext uri="{FF2B5EF4-FFF2-40B4-BE49-F238E27FC236}">
+                <a16:creationId xmlns:a16="http://schemas.microsoft.com/office/drawing/2014/main" id="{59E97641-0A9F-1646-3262-BDDF79279BDA}"/>
+              </a:ext>
+            </a:extLst>
+          </p:cNvPr>
+          <p:cNvSpPr/>
+          <p:nvPr/>
+        </p:nvSpPr>
+        <p:spPr>
+          <a:xfrm>
+            <a:off x="7028688" y="3320796"/>
+            <a:ext cx="3212592" cy="1478280"/>
+          </a:xfrm>
+          <a:prstGeom prst="rect">
+            <a:avLst/>
+          </a:prstGeom>
+        </p:spPr>
+        <p:style>
+          <a:lnRef idx="2">
+            <a:schemeClr val="accent4"/>
+          </a:lnRef>
+          <a:fillRef idx="1">
+            <a:schemeClr val="lt1"/>
+          </a:fillRef>
+          <a:effectRef idx="0">
+            <a:schemeClr val="accent4"/>
+          </a:effectRef>
+          <a:fontRef idx="minor">
+            <a:schemeClr val="dk1"/>
+          </a:fontRef>
+        </p:style>
+        <p:txBody>
+          <a:bodyPr rtlCol="0" anchor="t"/>
+          <a:lstStyle/>
+          <a:p>
+            <a:pPr algn="ctr"/>
+            <a:r>
+              <a:rPr lang="en-US" dirty="0"/>
+              <a:t>ID – title – username </a:t>
+            </a:r>
+          </a:p>
+          <a:p>
+            <a:pPr algn="ctr"/>
+            <a:r>
+              <a:rPr lang="en-US" dirty="0"/>
+              <a:t>.</a:t>
+            </a:r>
+          </a:p>
+          <a:p>
+            <a:pPr algn="ctr"/>
+            <a:r>
+              <a:rPr lang="en-US" dirty="0"/>
+              <a:t>.</a:t>
+            </a:r>
+          </a:p>
+          <a:p>
+            <a:pPr algn="ctr"/>
+            <a:r>
+              <a:rPr lang="en-US" dirty="0"/>
+              <a:t>.</a:t>
+            </a:r>
+          </a:p>
+          <a:p>
+            <a:pPr algn="ctr"/>
+            <a:r>
+              <a:rPr lang="en-US" dirty="0"/>
+              <a:t>.</a:t>
+            </a:r>
+          </a:p>
+        </p:txBody>
+      </p:sp>
+      <p:sp>
+        <p:nvSpPr>
+          <p:cNvPr id="10" name="Rectangle 9">
+            <a:extLst>
+              <a:ext uri="{FF2B5EF4-FFF2-40B4-BE49-F238E27FC236}">
+                <a16:creationId xmlns:a16="http://schemas.microsoft.com/office/drawing/2014/main" id="{A0437D79-E130-2296-42C4-919C6F41B6F8}"/>
+              </a:ext>
+            </a:extLst>
+          </p:cNvPr>
+          <p:cNvSpPr/>
+          <p:nvPr/>
+        </p:nvSpPr>
+        <p:spPr>
+          <a:xfrm>
+            <a:off x="7028688" y="4956048"/>
+            <a:ext cx="1456944" cy="359664"/>
+          </a:xfrm>
+          <a:prstGeom prst="rect">
+            <a:avLst/>
+          </a:prstGeom>
+        </p:spPr>
+        <p:style>
+          <a:lnRef idx="2">
+            <a:schemeClr val="accent6"/>
+          </a:lnRef>
+          <a:fillRef idx="1">
+            <a:schemeClr val="lt1"/>
+          </a:fillRef>
+          <a:effectRef idx="0">
+            <a:schemeClr val="accent6"/>
+          </a:effectRef>
+          <a:fontRef idx="minor">
+            <a:schemeClr val="dk1"/>
+          </a:fontRef>
+        </p:style>
+        <p:txBody>
+          <a:bodyPr rtlCol="0" anchor="t"/>
+          <a:lstStyle/>
+          <a:p>
+            <a:pPr algn="ctr"/>
+            <a:r>
+              <a:rPr lang="en-US" dirty="0"/>
+              <a:t>Prev post</a:t>
+            </a:r>
+          </a:p>
+        </p:txBody>
+      </p:sp>
+      <p:sp>
+        <p:nvSpPr>
+          <p:cNvPr id="11" name="Rectangle 10">
+            <a:extLst>
+              <a:ext uri="{FF2B5EF4-FFF2-40B4-BE49-F238E27FC236}">
+                <a16:creationId xmlns:a16="http://schemas.microsoft.com/office/drawing/2014/main" id="{B3F33C73-2C9D-3EC0-D2CE-97FFB849CBF5}"/>
+              </a:ext>
+            </a:extLst>
+          </p:cNvPr>
+          <p:cNvSpPr/>
+          <p:nvPr/>
+        </p:nvSpPr>
+        <p:spPr>
+          <a:xfrm>
+            <a:off x="8721852" y="4956048"/>
+            <a:ext cx="1456944" cy="359664"/>
+          </a:xfrm>
+          <a:prstGeom prst="rect">
+            <a:avLst/>
+          </a:prstGeom>
+        </p:spPr>
+        <p:style>
+          <a:lnRef idx="2">
+            <a:schemeClr val="accent6"/>
+          </a:lnRef>
+          <a:fillRef idx="1">
+            <a:schemeClr val="lt1"/>
+          </a:fillRef>
+          <a:effectRef idx="0">
+            <a:schemeClr val="accent6"/>
+          </a:effectRef>
+          <a:fontRef idx="minor">
+            <a:schemeClr val="dk1"/>
+          </a:fontRef>
+        </p:style>
+        <p:txBody>
+          <a:bodyPr rtlCol="0" anchor="t"/>
+          <a:lstStyle/>
+          <a:p>
+            <a:pPr algn="ctr"/>
+            <a:r>
+              <a:rPr lang="en-US" dirty="0"/>
+              <a:t>Next post</a:t>
+            </a:r>
+          </a:p>
+        </p:txBody>
+      </p:sp>
+    </p:spTree>
+    <p:extLst>
+      <p:ext uri="{BB962C8B-B14F-4D97-AF65-F5344CB8AC3E}">
+        <p14:creationId xmlns:p14="http://schemas.microsoft.com/office/powerpoint/2010/main" val="845911360"/>
+      </p:ext>
+    </p:extLst>
+  </p:cSld>
+  <p:clrMapOvr>
+    <a:masterClrMapping/>
+  </p:clrMapOvr>
+</p:sld>
+</file>
+
+<file path=ppt/slides/slide7.xml><?xml version="1.0" encoding="utf-8"?>
+<p:sld xmlns:a="http://schemas.openxmlformats.org/drawingml/2006/main" xmlns:r="http://schemas.openxmlformats.org/officeDocument/2006/relationships" xmlns:p="http://schemas.openxmlformats.org/presentationml/2006/main">
+  <p:cSld>
+    <p:spTree>
+      <p:nvGrpSpPr>
+        <p:cNvPr id="1" name=""/>
+        <p:cNvGrpSpPr/>
+        <p:nvPr/>
+      </p:nvGrpSpPr>
+      <p:grpSpPr>
+        <a:xfrm>
+          <a:off x="0" y="0"/>
+          <a:ext cx="0" cy="0"/>
+          <a:chOff x="0" y="0"/>
+          <a:chExt cx="0" cy="0"/>
+        </a:xfrm>
+      </p:grpSpPr>
+      <p:sp>
+        <p:nvSpPr>
+          <p:cNvPr id="2" name="Title 1">
+            <a:extLst>
+              <a:ext uri="{FF2B5EF4-FFF2-40B4-BE49-F238E27FC236}">
+                <a16:creationId xmlns:a16="http://schemas.microsoft.com/office/drawing/2014/main" id="{DAE49D1C-DA68-1367-2688-824F791CB838}"/>
+              </a:ext>
+            </a:extLst>
+          </p:cNvPr>
+          <p:cNvSpPr>
+            <a:spLocks noGrp="1"/>
+          </p:cNvSpPr>
+          <p:nvPr>
+            <p:ph type="title"/>
+          </p:nvPr>
+        </p:nvSpPr>
+        <p:spPr/>
+        <p:txBody>
+          <a:bodyPr/>
+          <a:lstStyle/>
+          <a:p>
+            <a:r>
+              <a:rPr lang="en-US" dirty="0"/>
+              <a:t>Post detail page</a:t>
+            </a:r>
+          </a:p>
+        </p:txBody>
+      </p:sp>
+      <p:sp>
+        <p:nvSpPr>
+          <p:cNvPr id="4" name="Slide Number Placeholder 3">
+            <a:extLst>
+              <a:ext uri="{FF2B5EF4-FFF2-40B4-BE49-F238E27FC236}">
+                <a16:creationId xmlns:a16="http://schemas.microsoft.com/office/drawing/2014/main" id="{918CF089-E2AA-B8D6-3446-E17A9104FD5E}"/>
+              </a:ext>
+            </a:extLst>
+          </p:cNvPr>
+          <p:cNvSpPr>
+            <a:spLocks noGrp="1"/>
+          </p:cNvSpPr>
+          <p:nvPr>
+            <p:ph type="sldNum" sz="quarter" idx="12"/>
+          </p:nvPr>
+        </p:nvSpPr>
+        <p:spPr/>
+        <p:txBody>
+          <a:bodyPr/>
+          <a:lstStyle/>
+          <a:p>
+            <a:fld id="{84C450F2-3BB4-4AE4-8A35-A9D7AEA4C850}" type="slidenum">
+              <a:rPr lang="en-US" smtClean="0"/>
+              <a:t>7</a:t>
             </a:fld>
             <a:endParaRPr lang="en-US" dirty="0"/>
           </a:p>
@@ -21326,7 +21537,7 @@
 </p:sld>
 </file>
 
-<file path=ppt/slides/slide7.xml><?xml version="1.0" encoding="utf-8"?>
+<file path=ppt/slides/slide8.xml><?xml version="1.0" encoding="utf-8"?>
 <p:sld xmlns:a="http://schemas.openxmlformats.org/drawingml/2006/main" xmlns:r="http://schemas.openxmlformats.org/officeDocument/2006/relationships" xmlns:p="http://schemas.openxmlformats.org/presentationml/2006/main">
   <p:cSld>
     <p:spTree>
@@ -21400,7 +21611,7 @@
           <a:p>
             <a:fld id="{84C450F2-3BB4-4AE4-8A35-A9D7AEA4C850}" type="slidenum">
               <a:rPr lang="en-US" smtClean="0"/>
-              <a:t>7</a:t>
+              <a:t>8</a:t>
             </a:fld>
             <a:endParaRPr lang="en-US" dirty="0"/>
           </a:p>
@@ -22350,15 +22561,6 @@
 </file>
 
 <file path=customXml/item2.xml><?xml version="1.0" encoding="utf-8"?>
-<?mso-contentType ?>
-<FormTemplates xmlns="http://schemas.microsoft.com/sharepoint/v3/contenttype/forms">
-  <Display>DocumentLibraryForm</Display>
-  <Edit>DocumentLibraryForm</Edit>
-  <New>DocumentLibraryForm</New>
-</FormTemplates>
-</file>
-
-<file path=customXml/item3.xml><?xml version="1.0" encoding="utf-8"?>
 <ct:contentTypeSchema xmlns:ct="http://schemas.microsoft.com/office/2006/metadata/contentType" xmlns:ma="http://schemas.microsoft.com/office/2006/metadata/properties/metaAttributes" ct:_="" ma:_="" ma:contentTypeName="Document" ma:contentTypeID="0x01010079F111ED35F8CC479449609E8A0923A6" ma:contentTypeVersion="30" ma:contentTypeDescription="Create a new document." ma:contentTypeScope="" ma:versionID="cec0622158e8f13124e9e8fd4de31bd1">
   <xsd:schema xmlns:xsd="http://www.w3.org/2001/XMLSchema" xmlns:xs="http://www.w3.org/2001/XMLSchema" xmlns:p="http://schemas.microsoft.com/office/2006/metadata/properties" xmlns:ns1="http://schemas.microsoft.com/sharepoint/v3" xmlns:ns2="71af3243-3dd4-4a8d-8c0d-dd76da1f02a5" xmlns:ns3="16c05727-aa75-4e4a-9b5f-8a80a1165891" xmlns:ns4="230e9df3-be65-4c73-a93b-d1236ebd677e" targetNamespace="http://schemas.microsoft.com/office/2006/metadata/properties" ma:root="true" ma:fieldsID="3b52f30ab005d15df08657af532e6e38" ns1:_="" ns2:_="" ns3:_="" ns4:_="">
     <xsd:import namespace="http://schemas.microsoft.com/sharepoint/v3"/>
@@ -22676,6 +22878,15 @@
 </ct:contentTypeSchema>
 </file>
 
+<file path=customXml/item3.xml><?xml version="1.0" encoding="utf-8"?>
+<?mso-contentType ?>
+<FormTemplates xmlns="http://schemas.microsoft.com/sharepoint/v3/contenttype/forms">
+  <Display>DocumentLibraryForm</Display>
+  <Edit>DocumentLibraryForm</Edit>
+  <New>DocumentLibraryForm</New>
+</FormTemplates>
+</file>
+
 <file path=customXml/itemProps1.xml><?xml version="1.0" encoding="utf-8"?>
 <ds:datastoreItem xmlns:ds="http://schemas.openxmlformats.org/officeDocument/2006/customXml" ds:itemID="{BD6282DC-5D67-4C19-9A05-C65D9BF7BC78}">
   <ds:schemaRefs>
@@ -22689,14 +22900,6 @@
 </file>
 
 <file path=customXml/itemProps2.xml><?xml version="1.0" encoding="utf-8"?>
-<ds:datastoreItem xmlns:ds="http://schemas.openxmlformats.org/officeDocument/2006/customXml" ds:itemID="{73667383-B7F3-43FC-8965-135FDDEABCC5}">
-  <ds:schemaRefs>
-    <ds:schemaRef ds:uri="http://schemas.microsoft.com/sharepoint/v3/contenttype/forms"/>
-  </ds:schemaRefs>
-</ds:datastoreItem>
-</file>
-
-<file path=customXml/itemProps3.xml><?xml version="1.0" encoding="utf-8"?>
 <ds:datastoreItem xmlns:ds="http://schemas.openxmlformats.org/officeDocument/2006/customXml" ds:itemID="{12135656-72CC-4564-823F-B30D0299644B}">
   <ds:schemaRefs>
     <ds:schemaRef ds:uri="http://schemas.microsoft.com/office/2006/metadata/contentType"/>
@@ -22717,6 +22920,14 @@
 </ds:datastoreItem>
 </file>
 
+<file path=customXml/itemProps3.xml><?xml version="1.0" encoding="utf-8"?>
+<ds:datastoreItem xmlns:ds="http://schemas.openxmlformats.org/officeDocument/2006/customXml" ds:itemID="{73667383-B7F3-43FC-8965-135FDDEABCC5}">
+  <ds:schemaRefs>
+    <ds:schemaRef ds:uri="http://schemas.microsoft.com/sharepoint/v3/contenttype/forms"/>
+  </ds:schemaRefs>
+</ds:datastoreItem>
+</file>
+
 <file path=docMetadata/LabelInfo.xml><?xml version="1.0" encoding="utf-8"?>
 <clbl:labelList xmlns:clbl="http://schemas.microsoft.com/office/2020/mipLabelMetadata"/>
 </file>
</xml_diff>